<commit_message>
Embed mixed and split demo playback and document presentation sources
</commit_message>
<xml_diff>
--- a/docs/presentation/2026-10-16/vismAI.pptx
+++ b/docs/presentation/2026-10-16/vismAI.pptx
@@ -21,6 +21,10 @@
       <p:bold r:id="rId7"/>
       <p:italic r:id="rId8"/>
       <p:boldItalic r:id="rId9"/>
+    </p:embeddedFont>
+    <p:embeddedFont>
+      <p:font typeface="Poppins" panose="00000500000000000000" pitchFamily="2" charset="0"/>
+      <p:bold r:id="rId10"/>
     </p:embeddedFont>
   </p:embeddedFontLst>
   <p:defaultTextStyle>
@@ -337,21 +341,26 @@
           <a:lstStyle/>
           <a:p>
             <a:r>
-              <a:t>Slide 1: outputs from separation and diarization
-### Vismay: 0:00–1:00, including 15 seconds of audio
+              <a:rPr lang="en-US"/>
+              <a:t>Slide 1 — Vismay: opening and separation
+[DO NOT READ ALOUD: Start on slide 1.]
 Good morning. We are team vismAI. Our project, whospoke, identifies who spoke what and when in noisy Hindi–English conversations.
-We will show the actual saved outputs. This example combines real Hindi speech with market noise and overlapping voices. It is a simulated test conversation.
-I handled Milestone 1, separation. These are two output clips from Conv-TasNet, taken from the same overlapping stretch.
-[Vismay: click Speaker A, then Speaker B, about 7.5 seconds each. If PC playback fails, say: “We'll play the same clips from the phone.” Keep slide 1 visible and play the downloaded clips from Darshan's phone, A then B. You own this fallback. Do not replay a clip that already worked. If the phone also fails, continue with the visible outputs.]
-Across 245 test overlap regions, the separator improves SI-SDR by 9.6 decibels. That measures separation quality, not transcription accuracy. Darshan will show the speaker timeline.
-### Darshan: 1:00–1:45
-I handled Milestone 2: who spoke when. The table is directly from our timeline output. It assigns Speaker A from 26.85 to 31.75 seconds, then Speaker B, then Speaker A again.
-We detect speech, extract short-window voice embeddings, and cluster similar embeddings into speaker groups. The output is anonymous speaker labels with start and end times.
-Our spectral configuration has 20.3 percent diarization error. GMM also gets 20.3, while the complete pyannote baseline gets 18.4. So we do not claim to beat that baseline.
-In our chosen order, we diarize the original recording first, then separate the detected overlaps.
-[Next slide.]
-Sources: results/demo/timeline.json; results/separation_test_summary.csv; results/eval_test_indicconformer.csv; docs/presentation/demo-video/make_speaker_clips.py. Clips demonstrate standalone full-recording separation, not the overlap-only evaluation.</a:t>
+This simulated test conversation combines real Hindi speech, overlapping voices and market noise.
+I handled Milestone One, separation. First, the mixed recording. Then, the two separated voices from an overlapping stretch within it.
+[DO NOT READ ALOUD: Play Mixed recording first, about 18 seconds. Then play Speaker A and Speaker B, about 7.5 seconds each. If PC audio fails, read the fallback sentence below, then play the downloaded clips from YOUR OWN phone. Keep slide 1 visible. Do not replay a clip that already worked. Return here after playback. If both playback methods fail, continue immediately.]
+[DO NOT READ ALOUD: Say the following sentence ONLY if switching to phone audio.]
+We'll play the same clips from the phone.
+[DO NOT READ ALOUD: RESUME HERE after playback.]
+Separation improves S-I-S-D-R by nine point six decibels across two hundred and forty-five test overlap regions. Darshan will explain the speaker timeline.
+Slide 1 — Darshan: your M2 output
+I handled Milestone Two: who spoke when. This actual timeline labels Speaker A, then B, then A again, with start and end times.
+We detect speech, extract short-window voice embeddings, and cluster similar embeddings into speaker groups. The labels are anonymous.
+Our spectral configuration has twenty point three percent diarization error. The pyannote baseline gets eighteen point four; we do not beat it.
+Our design decision was to diarize first, then separate detected overlaps. The next slide shows the difference.
+[DO NOT READ ALOUD: Advance to slide 2. Vismay speaks next.]
+Sources: see DATA_AND_SOURCES.md in docs/presentation/2026-10-16. Project evidence from commit 8465f0b.</a:t>
             </a:r>
+            <a:endParaRPr/>
           </a:p>
         </p:txBody>
       </p:sp>
@@ -427,16 +436,20 @@
           <a:lstStyle/>
           <a:p>
             <a:r>
-              <a:t>Slide 2: actual transcription output
-### Darshan: 1:45–2:40
-Abhinav handled Milestone 3. These lines are copied from the saved Hinglish transcript, with the predicted speakers and timestamps. The system also saves Devanagari text, subtitles and JSON.
-[Point to the first line, then the Speaker B reply. Do not read all three lines.]
-For speech recognition alone, IndicConformer gets 21 percent word error on 400 Vaani clips, compared with 38 percent for IndicWav2Vec.
-The full-pipeline comparison is a different test: 72 simulated conversations, about 83 minutes, across eight speaker groups. cpWER measures both word errors and speaker attribution errors.
-Separating first gives 55.8 percent cpWER. Diarizing first gives 49.5, and wins in 50 of the 72 conversations. Errors remain substantial, especially in assigning speech to the right speaker.
-[Next slide.]
-Sources: results/demo/transcript.json; results/asr_comparison.csv; results/eval_test_indicconformer.csv.</a:t>
+              <a:rPr lang="en-US"/>
+              <a:t>Slide 2 — Vismay: transcript output
+Abhinav handled Milestone Three. These saved Hinglish lines retain speakers and timestamps. We also output Devanagari and subtitles.
+For speech recognition alone, IndicConformer gets twenty-one percent word error on four hundred Vaani clips, compared with thirty-eight percent for IndicWav2Vec.
+Darshan will explain the full-pipeline comparison on the right.
+Slide 2 — Darshan: the main result
+We tested both orders on the same seventy-two simulated conversations, about eighty-three minutes across eight speaker groups.
+Our metric, C-P-W-E-R, measures word errors and speaker attribution errors. Lower is better.
+Separating first gives fifty-five point eight percent. Diarizing first gives forty-nine point five, and wins in fifty of the seventy-two conversations.
+The order matters. We implemented both and chose using measured outputs. Errors remain substantial; the problem is not solved.
+[DO NOT READ ALOUD: Advance to slide 3. Vismay speaks next.]
+Sources: see DATA_AND_SOURCES.md in docs/presentation/2026-10-16. Project evidence from commit 8465f0b.</a:t>
             </a:r>
+            <a:endParaRPr/>
           </a:p>
         </p:txBody>
       </p:sp>
@@ -512,14 +525,18 @@
           <a:lstStyle/>
           <a:p>
             <a:r>
-              <a:t>Slide 3: report output and next steps
-### Darshan: 2:40–3:40
-Shrivaths handled Milestone 4. Airavata produces a report with a summary, keywords and translated dialogue. On the left are actual excerpts: the lost ID card, and the question about office hours.
-The report keeps speaker labels and timestamps unchanged. But producing a report does not mean the report is fully reliable. On 63 evaluated conversations, transcript repair adds 0.9 cpWER points on average. No accepted action items remain in the 252 evaluated reports.
-So the Stage-3 transcript remains the record, and the report is a reading aid that needs checking.
-Our proposed next steps are to improve Hindi speaker embeddings, evaluate a larger LLM for action items, and retrain separation on Indian voices and noise. These are future experiments, not completed improvements. Thank you.
-Sources: results/demo/report.md; results/eval_postprocess.csv; docs/presentation/demo-video/deck/slides/next.html.</a:t>
+              <a:rPr lang="en-US"/>
+              <a:t>Slide 3 — Vismay: report output and its limits
+Shrivaths handled Milestone Four. Airavata produces summaries, keywords and translated dialogue. These saved excerpts concern a lost ID card and office hours.
+Speaker labels and times stay unchanged. But transcript repair adds zero point nine C-P-W-E-R points on average across sixty-three conversations. No accepted action items remain in the two hundred and fifty-two evaluated reports.
+So the original transcript remains the record, and the report needs checking.
+Slide 3 — Darshan: closing
+Our next steps are to improve Hindi speaker embeddings, evaluate a larger language model for action items, and retrain separation on Indian voices and noise.
+These are proposed experiments. Today we have shown every stage's output, the measured benefit of changing the order, and the remaining limitations. Thank you.
+[DO NOT READ ALOUD: End. Vismay answers M1 questions, Darshan M2, Abhinav M3 and Shrivaths M4.]
+Sources: see DATA_AND_SOURCES.md in docs/presentation/2026-10-16. Project evidence from commit 8465f0b.</a:t>
             </a:r>
+            <a:endParaRPr/>
           </a:p>
         </p:txBody>
       </p:sp>
@@ -572,7 +589,7 @@
           <p:cNvPr id="3" name="Title">
             <a:extLst>
               <a:ext uri="{FF2B5EF4-FFF2-40B4-BE49-F238E27FC236}">
-                <a16:creationId xmlns:a16="http://schemas.microsoft.com/office/drawing/2014/main" id="{8D191D04-DB99-4CB8-B95F-951AB042A64F}"/>
+                <a16:creationId xmlns:a16="http://schemas.microsoft.com/office/drawing/2014/main" id="{9A8D4BED-48B8-42D7-BAF3-5514EE11BB0B}"/>
               </a:ext>
             </a:extLst>
           </p:cNvPr>
@@ -731,7 +748,7 @@
           <p:cNvPr id="2" name="Subtitle">
             <a:extLst>
               <a:ext uri="{FF2B5EF4-FFF2-40B4-BE49-F238E27FC236}">
-                <a16:creationId xmlns:a16="http://schemas.microsoft.com/office/drawing/2014/main" id="{C260681C-A2B2-4BDA-A7C9-3C92B8880B14}"/>
+                <a16:creationId xmlns:a16="http://schemas.microsoft.com/office/drawing/2014/main" id="{D11DB31F-1CA3-4B75-BCCC-7CC921FE5E54}"/>
               </a:ext>
             </a:extLst>
           </p:cNvPr>
@@ -915,7 +932,7 @@
           <p:cNvPr id="2" name="Section title">
             <a:extLst>
               <a:ext uri="{FF2B5EF4-FFF2-40B4-BE49-F238E27FC236}">
-                <a16:creationId xmlns:a16="http://schemas.microsoft.com/office/drawing/2014/main" id="{274DEB96-F075-4AED-B615-F20004655AF4}"/>
+                <a16:creationId xmlns:a16="http://schemas.microsoft.com/office/drawing/2014/main" id="{7915B1CD-981B-411D-B0F6-0C140BB28CFA}"/>
               </a:ext>
             </a:extLst>
           </p:cNvPr>
@@ -1099,7 +1116,7 @@
           <p:cNvPr id="3" name="Title">
             <a:extLst>
               <a:ext uri="{FF2B5EF4-FFF2-40B4-BE49-F238E27FC236}">
-                <a16:creationId xmlns:a16="http://schemas.microsoft.com/office/drawing/2014/main" id="{EC7354C2-B196-4631-B13A-284A38664138}"/>
+                <a16:creationId xmlns:a16="http://schemas.microsoft.com/office/drawing/2014/main" id="{082E9E20-5A95-46AB-BF9F-57599DE0EC3B}"/>
               </a:ext>
             </a:extLst>
           </p:cNvPr>
@@ -1258,7 +1275,7 @@
           <p:cNvPr id="2" name="Body">
             <a:extLst>
               <a:ext uri="{FF2B5EF4-FFF2-40B4-BE49-F238E27FC236}">
-                <a16:creationId xmlns:a16="http://schemas.microsoft.com/office/drawing/2014/main" id="{D5F7F319-2DC8-458D-B0FB-7B45B8CEF474}"/>
+                <a16:creationId xmlns:a16="http://schemas.microsoft.com/office/drawing/2014/main" id="{C1DBEE01-DB6B-4591-A250-C1275DFC434B}"/>
               </a:ext>
             </a:extLst>
           </p:cNvPr>
@@ -1442,7 +1459,7 @@
           <p:cNvPr id="4" name="Title">
             <a:extLst>
               <a:ext uri="{FF2B5EF4-FFF2-40B4-BE49-F238E27FC236}">
-                <a16:creationId xmlns:a16="http://schemas.microsoft.com/office/drawing/2014/main" id="{1BA502D9-7179-4DB1-84D4-1317F2D5126C}"/>
+                <a16:creationId xmlns:a16="http://schemas.microsoft.com/office/drawing/2014/main" id="{1F3D792B-6BA5-4686-89FD-E778D7C2AD76}"/>
               </a:ext>
             </a:extLst>
           </p:cNvPr>
@@ -1601,7 +1618,7 @@
           <p:cNvPr id="2" name="Left column">
             <a:extLst>
               <a:ext uri="{FF2B5EF4-FFF2-40B4-BE49-F238E27FC236}">
-                <a16:creationId xmlns:a16="http://schemas.microsoft.com/office/drawing/2014/main" id="{8B94CC8D-EC55-44D9-9DED-BD336E729417}"/>
+                <a16:creationId xmlns:a16="http://schemas.microsoft.com/office/drawing/2014/main" id="{1E6F27E7-F020-4CA1-91C7-1A34221C835A}"/>
               </a:ext>
             </a:extLst>
           </p:cNvPr>
@@ -1760,7 +1777,7 @@
           <p:cNvPr id="3" name="Right column">
             <a:extLst>
               <a:ext uri="{FF2B5EF4-FFF2-40B4-BE49-F238E27FC236}">
-                <a16:creationId xmlns:a16="http://schemas.microsoft.com/office/drawing/2014/main" id="{E9F7AC3C-66F9-4EF6-8E8B-DA3EB0CD1849}"/>
+                <a16:creationId xmlns:a16="http://schemas.microsoft.com/office/drawing/2014/main" id="{59D866EF-6120-47C3-9B30-CFB0AE849ABC}"/>
               </a:ext>
             </a:extLst>
           </p:cNvPr>
@@ -1944,7 +1961,7 @@
           <p:cNvPr id="3" name="Title">
             <a:extLst>
               <a:ext uri="{FF2B5EF4-FFF2-40B4-BE49-F238E27FC236}">
-                <a16:creationId xmlns:a16="http://schemas.microsoft.com/office/drawing/2014/main" id="{21B20DD0-FD9E-4187-B8E7-400A16CA8F6D}"/>
+                <a16:creationId xmlns:a16="http://schemas.microsoft.com/office/drawing/2014/main" id="{10C50D24-B965-49B6-ACEC-AA3238D11F38}"/>
               </a:ext>
             </a:extLst>
           </p:cNvPr>
@@ -2103,7 +2120,7 @@
           <p:cNvPr id="2" name="Left column">
             <a:extLst>
               <a:ext uri="{FF2B5EF4-FFF2-40B4-BE49-F238E27FC236}">
-                <a16:creationId xmlns:a16="http://schemas.microsoft.com/office/drawing/2014/main" id="{F9546FD2-70E0-4B6B-B75A-B3960654F1B8}"/>
+                <a16:creationId xmlns:a16="http://schemas.microsoft.com/office/drawing/2014/main" id="{74D551B8-EC58-4D0E-B324-2B56161950F3}"/>
               </a:ext>
             </a:extLst>
           </p:cNvPr>
@@ -2630,10 +2647,10 @@
       </p:grpSpPr>
       <p:sp>
         <p:nvSpPr>
-          <p:cNvPr id="15" name="Rectangle 14">
+          <p:cNvPr id="19" name="Rectangle 18">
             <a:extLst>
               <a:ext uri="{FF2B5EF4-FFF2-40B4-BE49-F238E27FC236}">
-                <a16:creationId xmlns:a16="http://schemas.microsoft.com/office/drawing/2014/main" id="{1E7BE494-7B7A-4469-A164-93BB5C04462C}"/>
+                <a16:creationId xmlns:a16="http://schemas.microsoft.com/office/drawing/2014/main" id="{D056A5BE-C193-465C-966D-095F9A45835D}"/>
               </a:ext>
             </a:extLst>
           </p:cNvPr>
@@ -2699,7 +2716,7 @@
           <p:cNvPr id="2" name="Rectangle 1">
             <a:extLst>
               <a:ext uri="{FF2B5EF4-FFF2-40B4-BE49-F238E27FC236}">
-                <a16:creationId xmlns:a16="http://schemas.microsoft.com/office/drawing/2014/main" id="{8ACC9433-5CAE-46B3-B010-A6FE931B1176}"/>
+                <a16:creationId xmlns:a16="http://schemas.microsoft.com/office/drawing/2014/main" id="{01D5E738-7B7E-4CEB-8D54-3D82F6F8F567}"/>
               </a:ext>
             </a:extLst>
           </p:cNvPr>
@@ -2765,7 +2782,7 @@
           <p:cNvPr id="3" name="Rectangle 2">
             <a:extLst>
               <a:ext uri="{FF2B5EF4-FFF2-40B4-BE49-F238E27FC236}">
-                <a16:creationId xmlns:a16="http://schemas.microsoft.com/office/drawing/2014/main" id="{B74A3632-8C71-41ED-BA73-5515F117E831}"/>
+                <a16:creationId xmlns:a16="http://schemas.microsoft.com/office/drawing/2014/main" id="{37A89043-FF89-4219-9FB0-61F09B4952E2}"/>
               </a:ext>
             </a:extLst>
           </p:cNvPr>
@@ -2831,7 +2848,7 @@
           <p:cNvPr id="4" name="Rectangle 3">
             <a:extLst>
               <a:ext uri="{FF2B5EF4-FFF2-40B4-BE49-F238E27FC236}">
-                <a16:creationId xmlns:a16="http://schemas.microsoft.com/office/drawing/2014/main" id="{2B58B338-BEBB-4557-B2DD-542CA8E5ED24}"/>
+                <a16:creationId xmlns:a16="http://schemas.microsoft.com/office/drawing/2014/main" id="{C7F9C625-5754-49B1-B063-39916969FCD8}"/>
               </a:ext>
             </a:extLst>
           </p:cNvPr>
@@ -2897,7 +2914,7 @@
           <p:cNvPr id="5" name="Rectangle 4">
             <a:extLst>
               <a:ext uri="{FF2B5EF4-FFF2-40B4-BE49-F238E27FC236}">
-                <a16:creationId xmlns:a16="http://schemas.microsoft.com/office/drawing/2014/main" id="{6F443C5A-E19A-44E3-965A-89693FEE02D4}"/>
+                <a16:creationId xmlns:a16="http://schemas.microsoft.com/office/drawing/2014/main" id="{A46EAC62-8C1F-43CC-956C-0830081CEFA6}"/>
               </a:ext>
             </a:extLst>
           </p:cNvPr>
@@ -2963,7 +2980,7 @@
           <p:cNvPr id="6" name="Rectangle 5">
             <a:extLst>
               <a:ext uri="{FF2B5EF4-FFF2-40B4-BE49-F238E27FC236}">
-                <a16:creationId xmlns:a16="http://schemas.microsoft.com/office/drawing/2014/main" id="{6CEAB573-D51E-4AFF-9668-1086E93C910B}"/>
+                <a16:creationId xmlns:a16="http://schemas.microsoft.com/office/drawing/2014/main" id="{C8E49900-8F1A-4D12-9ADF-14BD8B99093E}"/>
               </a:ext>
             </a:extLst>
           </p:cNvPr>
@@ -2989,37 +3006,37 @@
           <a:bodyPr lIns="0" tIns="0" rIns="0" bIns="0" anchor="t"/>
           <a:lstStyle>
             <a:defPPr>
-              <a:defRPr sz="1350" b="0">
-                <a:solidFill>
-                  <a:srgbClr val="5E5D59"/>
-                </a:solidFill>
-                <a:latin typeface="Georgia"/>
-                <a:ea typeface="Georgia"/>
-                <a:cs typeface="Georgia"/>
+              <a:defRPr sz="1500" b="1">
+                <a:solidFill>
+                  <a:srgbClr val="141413"/>
+                </a:solidFill>
+                <a:latin typeface="Poppins"/>
+                <a:ea typeface="Poppins"/>
+                <a:cs typeface="Poppins"/>
               </a:defRPr>
             </a:defPPr>
           </a:lstStyle>
           <a:p>
             <a:pPr>
-              <a:defRPr sz="1350" b="0">
-                <a:solidFill>
-                  <a:srgbClr val="5E5D59"/>
-                </a:solidFill>
-                <a:latin typeface="Georgia"/>
-                <a:ea typeface="Georgia"/>
-                <a:cs typeface="Georgia"/>
+              <a:defRPr sz="1500" b="1">
+                <a:solidFill>
+                  <a:srgbClr val="141413"/>
+                </a:solidFill>
+                <a:latin typeface="Poppins"/>
+                <a:ea typeface="Poppins"/>
+                <a:cs typeface="Poppins"/>
               </a:defRPr>
             </a:pPr>
             <a:r>
-              <a:rPr sz="1350" b="0">
-                <a:solidFill>
-                  <a:srgbClr val="5E5D59"/>
-                </a:solidFill>
-                <a:latin typeface="Georgia"/>
-                <a:ea typeface="Georgia"/>
-                <a:cs typeface="Georgia"/>
+              <a:rPr sz="1500" b="1">
+                <a:solidFill>
+                  <a:srgbClr val="141413"/>
+                </a:solidFill>
+                <a:latin typeface="Poppins"/>
+                <a:ea typeface="Poppins"/>
+                <a:cs typeface="Poppins"/>
               </a:rPr>
-              <a:t>Conv-TasNet output clips, 28.0–35.5 s</a:t>
+              <a:t>1  Mixed recording</a:t>
             </a:r>
           </a:p>
         </p:txBody>
@@ -3029,7 +3046,7 @@
           <p:cNvPr id="7" name="Picture 6">
             <a:extLst>
               <a:ext uri="{FF2B5EF4-FFF2-40B4-BE49-F238E27FC236}">
-                <a16:creationId xmlns:a16="http://schemas.microsoft.com/office/drawing/2014/main" id="{1A0433A8-DEDB-4BEB-BDE6-2EFE59F8D8F9}"/>
+                <a16:creationId xmlns:a16="http://schemas.microsoft.com/office/drawing/2014/main" id="{2CE46855-3EBF-4354-AA76-5D5838569227}"/>
               </a:ext>
             </a:extLst>
           </p:cNvPr>
@@ -3039,25 +3056,279 @@
           <p:nvPr/>
         </p:nvPicPr>
         <p:blipFill>
-          <a:blip r:embed="rId7"/>
+          <a:blip r:embed="rId9"/>
           <a:stretch/>
         </p:blipFill>
         <p:spPr>
           <a:xfrm>
-            <a:off x="616676" y="2905125"/>
-            <a:ext cx="5129349" cy="1447800"/>
+            <a:off x="609600" y="2809875"/>
+            <a:ext cx="3429000" cy="1928813"/>
           </a:xfrm>
           <a:prstGeom prst="rect">
             <a:avLst/>
           </a:prstGeom>
         </p:spPr>
       </p:pic>
+      <p:sp>
+        <p:nvSpPr>
+          <p:cNvPr id="8" name="Rectangle 7">
+            <a:extLst>
+              <a:ext uri="{FF2B5EF4-FFF2-40B4-BE49-F238E27FC236}">
+                <a16:creationId xmlns:a16="http://schemas.microsoft.com/office/drawing/2014/main" id="{AFAC3B5E-7018-4343-8333-EBB07013C596}"/>
+              </a:ext>
+            </a:extLst>
+          </p:cNvPr>
+          <p:cNvSpPr>
+            <a:spLocks noGrp="1"/>
+          </p:cNvSpPr>
+          <p:nvPr/>
+        </p:nvSpPr>
+        <p:spPr>
+          <a:xfrm>
+            <a:off x="4248150" y="3133725"/>
+            <a:ext cx="1504950" cy="1476375"/>
+          </a:xfrm>
+          <a:prstGeom prst="rect">
+            <a:avLst/>
+          </a:prstGeom>
+          <a:noFill/>
+          <a:ln w="0">
+            <a:noFill/>
+          </a:ln>
+        </p:spPr>
+        <p:txBody>
+          <a:bodyPr lIns="0" tIns="0" rIns="0" bIns="0" anchor="t"/>
+          <a:lstStyle>
+            <a:defPPr>
+              <a:defRPr sz="1425" b="0">
+                <a:solidFill>
+                  <a:srgbClr val="5E5D59"/>
+                </a:solidFill>
+                <a:latin typeface="Georgia"/>
+                <a:ea typeface="Georgia"/>
+                <a:cs typeface="Georgia"/>
+              </a:defRPr>
+            </a:defPPr>
+          </a:lstStyle>
+          <a:p>
+            <a:pPr>
+              <a:defRPr sz="1425" b="0">
+                <a:solidFill>
+                  <a:srgbClr val="5E5D59"/>
+                </a:solidFill>
+                <a:latin typeface="Georgia"/>
+                <a:ea typeface="Georgia"/>
+                <a:cs typeface="Georgia"/>
+              </a:defRPr>
+            </a:pPr>
+            <a:r>
+              <a:rPr sz="1425" b="0">
+                <a:solidFill>
+                  <a:srgbClr val="5E5D59"/>
+                </a:solidFill>
+                <a:latin typeface="Georgia"/>
+                <a:ea typeface="Georgia"/>
+                <a:cs typeface="Georgia"/>
+              </a:rPr>
+              <a:t>26.4–44.8 s</a:t>
+            </a:r>
+          </a:p>
+          <a:p>
+            <a:pPr>
+              <a:defRPr sz="1425" b="0">
+                <a:solidFill>
+                  <a:srgbClr val="5E5D59"/>
+                </a:solidFill>
+                <a:latin typeface="Georgia"/>
+                <a:ea typeface="Georgia"/>
+                <a:cs typeface="Georgia"/>
+              </a:defRPr>
+            </a:pPr>
+            <a:r>
+              <a:rPr sz="1425" b="0">
+                <a:solidFill>
+                  <a:srgbClr val="5E5D59"/>
+                </a:solidFill>
+                <a:latin typeface="Georgia"/>
+                <a:ea typeface="Georgia"/>
+                <a:cs typeface="Georgia"/>
+              </a:rPr>
+              <a:t>Original mixture</a:t>
+            </a:r>
+          </a:p>
+          <a:p>
+            <a:endParaRPr sz="1425" b="0">
+              <a:solidFill>
+                <a:srgbClr val="5E5D59"/>
+              </a:solidFill>
+              <a:latin typeface="Georgia"/>
+              <a:ea typeface="Georgia"/>
+              <a:cs typeface="Georgia"/>
+            </a:endParaRPr>
+          </a:p>
+          <a:p>
+            <a:pPr>
+              <a:defRPr sz="1425" b="0">
+                <a:solidFill>
+                  <a:srgbClr val="5E5D59"/>
+                </a:solidFill>
+                <a:latin typeface="Georgia"/>
+                <a:ea typeface="Georgia"/>
+                <a:cs typeface="Georgia"/>
+              </a:defRPr>
+            </a:pPr>
+            <a:r>
+              <a:rPr sz="1425" b="0">
+                <a:solidFill>
+                  <a:srgbClr val="5E5D59"/>
+                </a:solidFill>
+                <a:latin typeface="Georgia"/>
+                <a:ea typeface="Georgia"/>
+                <a:cs typeface="Georgia"/>
+              </a:rPr>
+              <a:t>Click to play</a:t>
+            </a:r>
+          </a:p>
+        </p:txBody>
+      </p:sp>
+      <p:sp>
+        <p:nvSpPr>
+          <p:cNvPr id="9" name="Rectangle 8">
+            <a:extLst>
+              <a:ext uri="{FF2B5EF4-FFF2-40B4-BE49-F238E27FC236}">
+                <a16:creationId xmlns:a16="http://schemas.microsoft.com/office/drawing/2014/main" id="{BB62BF4F-8963-416E-8AED-56CCF1D5FC8E}"/>
+              </a:ext>
+            </a:extLst>
+          </p:cNvPr>
+          <p:cNvSpPr>
+            <a:spLocks noGrp="1"/>
+          </p:cNvSpPr>
+          <p:nvPr/>
+        </p:nvSpPr>
+        <p:spPr>
+          <a:xfrm>
+            <a:off x="609600" y="4895850"/>
+            <a:ext cx="2514600" cy="285750"/>
+          </a:xfrm>
+          <a:prstGeom prst="rect">
+            <a:avLst/>
+          </a:prstGeom>
+          <a:noFill/>
+          <a:ln w="0">
+            <a:noFill/>
+          </a:ln>
+        </p:spPr>
+        <p:txBody>
+          <a:bodyPr lIns="0" tIns="0" rIns="0" bIns="0" anchor="t"/>
+          <a:lstStyle>
+            <a:defPPr>
+              <a:defRPr sz="1500" b="1">
+                <a:solidFill>
+                  <a:srgbClr val="D97757"/>
+                </a:solidFill>
+                <a:latin typeface="Poppins"/>
+                <a:ea typeface="Poppins"/>
+                <a:cs typeface="Poppins"/>
+              </a:defRPr>
+            </a:defPPr>
+          </a:lstStyle>
+          <a:p>
+            <a:pPr>
+              <a:defRPr sz="1500" b="1">
+                <a:solidFill>
+                  <a:srgbClr val="D97757"/>
+                </a:solidFill>
+                <a:latin typeface="Poppins"/>
+                <a:ea typeface="Poppins"/>
+                <a:cs typeface="Poppins"/>
+              </a:defRPr>
+            </a:pPr>
+            <a:r>
+              <a:rPr sz="1500" b="1">
+                <a:solidFill>
+                  <a:srgbClr val="D97757"/>
+                </a:solidFill>
+                <a:latin typeface="Poppins"/>
+                <a:ea typeface="Poppins"/>
+                <a:cs typeface="Poppins"/>
+              </a:rPr>
+              <a:t>2  Speaker A</a:t>
+            </a:r>
+          </a:p>
+        </p:txBody>
+      </p:sp>
+      <p:sp>
+        <p:nvSpPr>
+          <p:cNvPr id="10" name="Rectangle 9">
+            <a:extLst>
+              <a:ext uri="{FF2B5EF4-FFF2-40B4-BE49-F238E27FC236}">
+                <a16:creationId xmlns:a16="http://schemas.microsoft.com/office/drawing/2014/main" id="{25870706-35A7-42EF-BDF4-7EBEF84A7468}"/>
+              </a:ext>
+            </a:extLst>
+          </p:cNvPr>
+          <p:cNvSpPr>
+            <a:spLocks noGrp="1"/>
+          </p:cNvSpPr>
+          <p:nvPr/>
+        </p:nvSpPr>
+        <p:spPr>
+          <a:xfrm>
+            <a:off x="3238500" y="4895850"/>
+            <a:ext cx="2514600" cy="285750"/>
+          </a:xfrm>
+          <a:prstGeom prst="rect">
+            <a:avLst/>
+          </a:prstGeom>
+          <a:noFill/>
+          <a:ln w="0">
+            <a:noFill/>
+          </a:ln>
+        </p:spPr>
+        <p:txBody>
+          <a:bodyPr lIns="0" tIns="0" rIns="0" bIns="0" anchor="t"/>
+          <a:lstStyle>
+            <a:defPPr>
+              <a:defRPr sz="1500" b="1">
+                <a:solidFill>
+                  <a:srgbClr val="6A9BCC"/>
+                </a:solidFill>
+                <a:latin typeface="Poppins"/>
+                <a:ea typeface="Poppins"/>
+                <a:cs typeface="Poppins"/>
+              </a:defRPr>
+            </a:defPPr>
+          </a:lstStyle>
+          <a:p>
+            <a:pPr>
+              <a:defRPr sz="1500" b="1">
+                <a:solidFill>
+                  <a:srgbClr val="6A9BCC"/>
+                </a:solidFill>
+                <a:latin typeface="Poppins"/>
+                <a:ea typeface="Poppins"/>
+                <a:cs typeface="Poppins"/>
+              </a:defRPr>
+            </a:pPr>
+            <a:r>
+              <a:rPr sz="1500" b="1">
+                <a:solidFill>
+                  <a:srgbClr val="6A9BCC"/>
+                </a:solidFill>
+                <a:latin typeface="Poppins"/>
+                <a:ea typeface="Poppins"/>
+                <a:cs typeface="Poppins"/>
+              </a:rPr>
+              <a:t>3  Speaker B</a:t>
+            </a:r>
+          </a:p>
+        </p:txBody>
+      </p:sp>
       <p:pic>
         <p:nvPicPr>
-          <p:cNvPr id="8" name="Picture 7">
+          <p:cNvPr id="11" name="Picture 10">
             <a:extLst>
               <a:ext uri="{FF2B5EF4-FFF2-40B4-BE49-F238E27FC236}">
-                <a16:creationId xmlns:a16="http://schemas.microsoft.com/office/drawing/2014/main" id="{E7782D7F-0CCC-4409-8EB0-5BDC62780A07}"/>
+                <a16:creationId xmlns:a16="http://schemas.microsoft.com/office/drawing/2014/main" id="{4B312234-FC07-4A9C-B248-9B454BA78B90}"/>
               </a:ext>
             </a:extLst>
           </p:cNvPr>
@@ -3067,13 +3338,41 @@
           <p:nvPr/>
         </p:nvPicPr>
         <p:blipFill>
-          <a:blip r:embed="rId8"/>
+          <a:blip r:embed="rId10"/>
           <a:stretch/>
         </p:blipFill>
         <p:spPr>
           <a:xfrm>
-            <a:off x="616676" y="4457700"/>
-            <a:ext cx="5129349" cy="1447800"/>
+            <a:off x="609600" y="5229243"/>
+            <a:ext cx="2514600" cy="709766"/>
+          </a:xfrm>
+          <a:prstGeom prst="rect">
+            <a:avLst/>
+          </a:prstGeom>
+        </p:spPr>
+      </p:pic>
+      <p:pic>
+        <p:nvPicPr>
+          <p:cNvPr id="12" name="Picture 11">
+            <a:extLst>
+              <a:ext uri="{FF2B5EF4-FFF2-40B4-BE49-F238E27FC236}">
+                <a16:creationId xmlns:a16="http://schemas.microsoft.com/office/drawing/2014/main" id="{B1DEC89B-B817-4801-9314-42449CF6A287}"/>
+              </a:ext>
+            </a:extLst>
+          </p:cNvPr>
+          <p:cNvPicPr>
+            <a:picLocks noChangeAspect="1"/>
+          </p:cNvPicPr>
+          <p:nvPr/>
+        </p:nvPicPr>
+        <p:blipFill>
+          <a:blip r:embed="rId11"/>
+          <a:stretch/>
+        </p:blipFill>
+        <p:spPr>
+          <a:xfrm>
+            <a:off x="3238500" y="5229243"/>
+            <a:ext cx="2514600" cy="709766"/>
           </a:xfrm>
           <a:prstGeom prst="rect">
             <a:avLst/>
@@ -3082,10 +3381,10 @@
       </p:pic>
       <p:sp>
         <p:nvSpPr>
-          <p:cNvPr id="9" name="Rectangle 8">
+          <p:cNvPr id="13" name="Rectangle 12">
             <a:extLst>
               <a:ext uri="{FF2B5EF4-FFF2-40B4-BE49-F238E27FC236}">
-                <a16:creationId xmlns:a16="http://schemas.microsoft.com/office/drawing/2014/main" id="{4DE4E936-185F-4B2B-9FDD-830FCAC710FA}"/>
+                <a16:creationId xmlns:a16="http://schemas.microsoft.com/office/drawing/2014/main" id="{E9F26EE4-09D8-4C38-B727-6F27AC0B906D}"/>
               </a:ext>
             </a:extLst>
           </p:cNvPr>
@@ -3148,10 +3447,10 @@
       </p:sp>
       <p:sp>
         <p:nvSpPr>
-          <p:cNvPr id="10" name="Rectangle 9">
+          <p:cNvPr id="14" name="Rectangle 13">
             <a:extLst>
               <a:ext uri="{FF2B5EF4-FFF2-40B4-BE49-F238E27FC236}">
-                <a16:creationId xmlns:a16="http://schemas.microsoft.com/office/drawing/2014/main" id="{5EDA2C75-A2BD-46C4-9FC1-F1435F01DCEE}"/>
+                <a16:creationId xmlns:a16="http://schemas.microsoft.com/office/drawing/2014/main" id="{5E7BC48E-9482-474E-B4C4-B0376955C6CC}"/>
               </a:ext>
             </a:extLst>
           </p:cNvPr>
@@ -3214,10 +3513,10 @@
       </p:sp>
       <p:sp>
         <p:nvSpPr>
-          <p:cNvPr id="11" name="Rectangle 10">
+          <p:cNvPr id="15" name="Rectangle 14">
             <a:extLst>
               <a:ext uri="{FF2B5EF4-FFF2-40B4-BE49-F238E27FC236}">
-                <a16:creationId xmlns:a16="http://schemas.microsoft.com/office/drawing/2014/main" id="{A08273FB-50E0-463A-A3B7-36D42F6F4FE5}"/>
+                <a16:creationId xmlns:a16="http://schemas.microsoft.com/office/drawing/2014/main" id="{5616CB34-0FB6-44B0-B6A2-68F061995C5D}"/>
               </a:ext>
             </a:extLst>
           </p:cNvPr>
@@ -3280,10 +3579,10 @@
       </p:sp>
       <p:graphicFrame>
         <p:nvGraphicFramePr>
-          <p:cNvPr id="12" name="Table 11">
+          <p:cNvPr id="16" name="Table 15">
             <a:extLst>
               <a:ext uri="{FF2B5EF4-FFF2-40B4-BE49-F238E27FC236}">
-                <a16:creationId xmlns:a16="http://schemas.microsoft.com/office/drawing/2014/main" id="{05FF459B-D481-4E2C-9C2F-E3E9CEBC0804}"/>
+                <a16:creationId xmlns:a16="http://schemas.microsoft.com/office/drawing/2014/main" id="{952911BE-CD4C-4F05-851A-736C7EF2B1D3}"/>
               </a:ext>
             </a:extLst>
           </p:cNvPr>
@@ -3951,10 +4250,10 @@
       </p:graphicFrame>
       <p:sp>
         <p:nvSpPr>
-          <p:cNvPr id="13" name="Rectangle 12">
+          <p:cNvPr id="17" name="Rectangle 16">
             <a:extLst>
               <a:ext uri="{FF2B5EF4-FFF2-40B4-BE49-F238E27FC236}">
-                <a16:creationId xmlns:a16="http://schemas.microsoft.com/office/drawing/2014/main" id="{813ED03E-A26B-4BDD-B018-1DCA8C75A5FC}"/>
+                <a16:creationId xmlns:a16="http://schemas.microsoft.com/office/drawing/2014/main" id="{A6E8D5BC-6A49-4CDE-ABD7-2EB74E8DBC78}"/>
               </a:ext>
             </a:extLst>
           </p:cNvPr>
@@ -4017,10 +4316,10 @@
       </p:sp>
       <p:sp>
         <p:nvSpPr>
-          <p:cNvPr id="14" name="Rectangle 13">
+          <p:cNvPr id="18" name="Rectangle 17">
             <a:extLst>
               <a:ext uri="{FF2B5EF4-FFF2-40B4-BE49-F238E27FC236}">
-                <a16:creationId xmlns:a16="http://schemas.microsoft.com/office/drawing/2014/main" id="{36784169-7F48-4028-B52E-813FC40FF4EF}"/>
+                <a16:creationId xmlns:a16="http://schemas.microsoft.com/office/drawing/2014/main" id="{F2F4DD35-19F4-48C3-8655-6742B28C3CD2}"/>
               </a:ext>
             </a:extLst>
           </p:cNvPr>
@@ -4106,11 +4405,11 @@
       </p:sp>
       <p:pic>
         <p:nvPicPr>
-          <p:cNvPr id="16" name="Play separated Speaker A">
+          <p:cNvPr id="20" name="Play Mixed recording">
             <a:hlinkClick action="ppaction://media"/>
             <a:extLst>
               <a:ext uri="{FF2B5EF4-FFF2-40B4-BE49-F238E27FC236}">
-                <a16:creationId xmlns:a16="http://schemas.microsoft.com/office/drawing/2014/main" id="{083D3CD1-98AA-5844-2E6A-9D4D2063C863}"/>
+                <a16:creationId xmlns:a16="http://schemas.microsoft.com/office/drawing/2014/main" id="{61103C39-112B-9E7A-A144-F1A2423F3A10}"/>
               </a:ext>
             </a:extLst>
           </p:cNvPr>
@@ -4127,15 +4426,15 @@
           </p:nvPr>
         </p:nvPicPr>
         <p:blipFill>
-          <a:blip r:embed="rId7"/>
+          <a:blip r:embed="rId9"/>
           <a:stretch>
             <a:fillRect/>
           </a:stretch>
         </p:blipFill>
         <p:spPr>
           <a:xfrm>
-            <a:off x="609601" y="2905125"/>
-            <a:ext cx="5129781" cy="1447800"/>
+            <a:off x="609600" y="2809876"/>
+            <a:ext cx="3429000" cy="1928813"/>
           </a:xfrm>
           <a:prstGeom prst="rect">
             <a:avLst/>
@@ -4144,11 +4443,11 @@
       </p:pic>
       <p:pic>
         <p:nvPicPr>
-          <p:cNvPr id="17" name="Play separated Speaker B">
+          <p:cNvPr id="21" name="Play Speaker A">
             <a:hlinkClick action="ppaction://media"/>
             <a:extLst>
               <a:ext uri="{FF2B5EF4-FFF2-40B4-BE49-F238E27FC236}">
-                <a16:creationId xmlns:a16="http://schemas.microsoft.com/office/drawing/2014/main" id="{3703A8D2-C485-9000-9EF2-57EAEB52804C}"/>
+                <a16:creationId xmlns:a16="http://schemas.microsoft.com/office/drawing/2014/main" id="{980D1EDC-80FE-E5A8-3DB9-8E6CFC35FC7F}"/>
               </a:ext>
             </a:extLst>
           </p:cNvPr>
@@ -4165,15 +4464,53 @@
           </p:nvPr>
         </p:nvPicPr>
         <p:blipFill>
-          <a:blip r:embed="rId8"/>
+          <a:blip r:embed="rId10"/>
           <a:stretch>
             <a:fillRect/>
           </a:stretch>
         </p:blipFill>
         <p:spPr>
           <a:xfrm>
-            <a:off x="609601" y="4457700"/>
-            <a:ext cx="5129781" cy="1447800"/>
+            <a:off x="609600" y="5229226"/>
+            <a:ext cx="2514940" cy="709803"/>
+          </a:xfrm>
+          <a:prstGeom prst="rect">
+            <a:avLst/>
+          </a:prstGeom>
+        </p:spPr>
+      </p:pic>
+      <p:pic>
+        <p:nvPicPr>
+          <p:cNvPr id="22" name="Play Speaker B">
+            <a:hlinkClick action="ppaction://media"/>
+            <a:extLst>
+              <a:ext uri="{FF2B5EF4-FFF2-40B4-BE49-F238E27FC236}">
+                <a16:creationId xmlns:a16="http://schemas.microsoft.com/office/drawing/2014/main" id="{E3D2B94B-ADE5-9146-1A3A-063A4B035D92}"/>
+              </a:ext>
+            </a:extLst>
+          </p:cNvPr>
+          <p:cNvPicPr>
+            <a:picLocks noChangeAspect="1"/>
+          </p:cNvPicPr>
+          <p:nvPr>
+            <a:videoFile r:link="rId6"/>
+            <p:extLst>
+              <p:ext uri="{DAA4B4D4-6D71-4841-9C94-3DE7FCFB9230}">
+                <p14:media xmlns:p14="http://schemas.microsoft.com/office/powerpoint/2010/main" r:embed="rId5"/>
+              </p:ext>
+            </p:extLst>
+          </p:nvPr>
+        </p:nvPicPr>
+        <p:blipFill>
+          <a:blip r:embed="rId11"/>
+          <a:stretch>
+            <a:fillRect/>
+          </a:stretch>
+        </p:blipFill>
+        <p:spPr>
+          <a:xfrm>
+            <a:off x="3238500" y="5229226"/>
+            <a:ext cx="2514940" cy="709803"/>
           </a:xfrm>
           <a:prstGeom prst="rect">
             <a:avLst/>
@@ -4183,7 +4520,7 @@
     </p:spTree>
     <p:extLst>
       <p:ext uri="{BB962C8B-B14F-4D97-AF65-F5344CB8AC3E}">
-        <p14:creationId xmlns:p14="http://schemas.microsoft.com/office/powerpoint/2010/main" val="211805177"/>
+        <p14:creationId xmlns:p14="http://schemas.microsoft.com/office/powerpoint/2010/main" val="1197299923"/>
       </p:ext>
     </p:extLst>
   </p:cSld>
@@ -4200,7 +4537,7 @@
                 <p:stCondLst>
                   <p:cond evt="onClick" delay="0">
                     <p:tgtEl>
-                      <p:spTgt spid="16"/>
+                      <p:spTgt spid="20"/>
                     </p:tgtEl>
                   </p:cond>
                 </p:stCondLst>
@@ -4230,7 +4567,7 @@
                                       <p:cBhvr>
                                         <p:cTn id="6" dur="1" fill="hold"/>
                                         <p:tgtEl>
-                                          <p:spTgt spid="16"/>
+                                          <p:spTgt spid="20"/>
                                         </p:tgtEl>
                                       </p:cBhvr>
                                     </p:cmd>
@@ -4248,7 +4585,7 @@
               <p:nextCondLst>
                 <p:cond evt="onClick" delay="0">
                   <p:tgtEl>
-                    <p:spTgt spid="16"/>
+                    <p:spTgt spid="20"/>
                   </p:tgtEl>
                 </p:cond>
               </p:nextCondLst>
@@ -4261,7 +4598,7 @@
                   </p:stCondLst>
                 </p:cTn>
                 <p:tgtEl>
-                  <p:spTgt spid="16"/>
+                  <p:spTgt spid="20"/>
                 </p:tgtEl>
               </p:cMediaNode>
             </p:video>
@@ -4270,7 +4607,7 @@
                 <p:stCondLst>
                   <p:cond evt="onClick" delay="0">
                     <p:tgtEl>
-                      <p:spTgt spid="17"/>
+                      <p:spTgt spid="21"/>
                     </p:tgtEl>
                   </p:cond>
                 </p:stCondLst>
@@ -4300,7 +4637,7 @@
                                       <p:cBhvr>
                                         <p:cTn id="12" dur="1" fill="hold"/>
                                         <p:tgtEl>
-                                          <p:spTgt spid="17"/>
+                                          <p:spTgt spid="21"/>
                                         </p:tgtEl>
                                       </p:cBhvr>
                                     </p:cmd>
@@ -4318,7 +4655,7 @@
               <p:nextCondLst>
                 <p:cond evt="onClick" delay="0">
                   <p:tgtEl>
-                    <p:spTgt spid="17"/>
+                    <p:spTgt spid="21"/>
                   </p:tgtEl>
                 </p:cond>
               </p:nextCondLst>
@@ -4331,7 +4668,77 @@
                   </p:stCondLst>
                 </p:cTn>
                 <p:tgtEl>
-                  <p:spTgt spid="17"/>
+                  <p:spTgt spid="21"/>
+                </p:tgtEl>
+              </p:cMediaNode>
+            </p:video>
+            <p:seq concurrent="1" nextAc="seek">
+              <p:cTn id="14" restart="whenNotActive" fill="hold" evtFilter="cancelBubble" nodeType="interactiveSeq">
+                <p:stCondLst>
+                  <p:cond evt="onClick" delay="0">
+                    <p:tgtEl>
+                      <p:spTgt spid="22"/>
+                    </p:tgtEl>
+                  </p:cond>
+                </p:stCondLst>
+                <p:endSync evt="end" delay="0">
+                  <p:rtn val="all"/>
+                </p:endSync>
+                <p:childTnLst>
+                  <p:par>
+                    <p:cTn id="15" fill="hold">
+                      <p:stCondLst>
+                        <p:cond delay="0"/>
+                      </p:stCondLst>
+                      <p:childTnLst>
+                        <p:par>
+                          <p:cTn id="16" fill="hold">
+                            <p:stCondLst>
+                              <p:cond delay="0"/>
+                            </p:stCondLst>
+                            <p:childTnLst>
+                              <p:par>
+                                <p:cTn id="17" presetID="2" presetClass="mediacall" presetSubtype="0" fill="hold" nodeType="clickEffect">
+                                  <p:stCondLst>
+                                    <p:cond delay="0"/>
+                                  </p:stCondLst>
+                                  <p:childTnLst>
+                                    <p:cmd type="call" cmd="togglePause">
+                                      <p:cBhvr>
+                                        <p:cTn id="18" dur="1" fill="hold"/>
+                                        <p:tgtEl>
+                                          <p:spTgt spid="22"/>
+                                        </p:tgtEl>
+                                      </p:cBhvr>
+                                    </p:cmd>
+                                  </p:childTnLst>
+                                </p:cTn>
+                              </p:par>
+                            </p:childTnLst>
+                          </p:cTn>
+                        </p:par>
+                      </p:childTnLst>
+                    </p:cTn>
+                  </p:par>
+                </p:childTnLst>
+              </p:cTn>
+              <p:nextCondLst>
+                <p:cond evt="onClick" delay="0">
+                  <p:tgtEl>
+                    <p:spTgt spid="22"/>
+                  </p:tgtEl>
+                </p:cond>
+              </p:nextCondLst>
+            </p:seq>
+            <p:video>
+              <p:cMediaNode vol="100000">
+                <p:cTn id="19" fill="hold" display="0">
+                  <p:stCondLst>
+                    <p:cond delay="indefinite"/>
+                  </p:stCondLst>
+                </p:cTn>
+                <p:tgtEl>
+                  <p:spTgt spid="22"/>
                 </p:tgtEl>
               </p:cMediaNode>
             </p:video>
@@ -4373,7 +4780,7 @@
           <p:cNvPr id="18" name="Rectangle 17">
             <a:extLst>
               <a:ext uri="{FF2B5EF4-FFF2-40B4-BE49-F238E27FC236}">
-                <a16:creationId xmlns:a16="http://schemas.microsoft.com/office/drawing/2014/main" id="{4896A10E-340F-48B8-AC89-1FBD2050E9C2}"/>
+                <a16:creationId xmlns:a16="http://schemas.microsoft.com/office/drawing/2014/main" id="{AA62083B-E921-42AC-974F-0D6DBC7B2D87}"/>
               </a:ext>
             </a:extLst>
           </p:cNvPr>
@@ -4439,7 +4846,7 @@
           <p:cNvPr id="2" name="Rectangle 1">
             <a:extLst>
               <a:ext uri="{FF2B5EF4-FFF2-40B4-BE49-F238E27FC236}">
-                <a16:creationId xmlns:a16="http://schemas.microsoft.com/office/drawing/2014/main" id="{A1883D9B-E0CA-44D1-94E9-5D16A9D173DF}"/>
+                <a16:creationId xmlns:a16="http://schemas.microsoft.com/office/drawing/2014/main" id="{C34B8659-01E7-4E60-919E-C88B2A46D880}"/>
               </a:ext>
             </a:extLst>
           </p:cNvPr>
@@ -4505,7 +4912,7 @@
           <p:cNvPr id="3" name="Rectangle 2">
             <a:extLst>
               <a:ext uri="{FF2B5EF4-FFF2-40B4-BE49-F238E27FC236}">
-                <a16:creationId xmlns:a16="http://schemas.microsoft.com/office/drawing/2014/main" id="{BDCB9A84-17C5-487C-A197-9216D04A7C45}"/>
+                <a16:creationId xmlns:a16="http://schemas.microsoft.com/office/drawing/2014/main" id="{8BF9B1FC-B44B-4064-8FC5-7C88036A8B00}"/>
               </a:ext>
             </a:extLst>
           </p:cNvPr>
@@ -4571,7 +4978,7 @@
           <p:cNvPr id="4" name="Rectangle 3">
             <a:extLst>
               <a:ext uri="{FF2B5EF4-FFF2-40B4-BE49-F238E27FC236}">
-                <a16:creationId xmlns:a16="http://schemas.microsoft.com/office/drawing/2014/main" id="{CB527623-7BF8-463B-905A-19EA3724BC50}"/>
+                <a16:creationId xmlns:a16="http://schemas.microsoft.com/office/drawing/2014/main" id="{82A92B46-EB49-4D12-876E-94F86FD7C8D8}"/>
               </a:ext>
             </a:extLst>
           </p:cNvPr>
@@ -4637,7 +5044,7 @@
           <p:cNvPr id="5" name="Rectangle 4">
             <a:extLst>
               <a:ext uri="{FF2B5EF4-FFF2-40B4-BE49-F238E27FC236}">
-                <a16:creationId xmlns:a16="http://schemas.microsoft.com/office/drawing/2014/main" id="{884E8417-8992-44AE-8D54-5ACEC02AC19F}"/>
+                <a16:creationId xmlns:a16="http://schemas.microsoft.com/office/drawing/2014/main" id="{91D7E2E4-E4F3-4A99-A16E-3D135FFC4BDC}"/>
               </a:ext>
             </a:extLst>
           </p:cNvPr>
@@ -4703,7 +5110,7 @@
           <p:cNvPr id="6" name="Rectangle 5">
             <a:extLst>
               <a:ext uri="{FF2B5EF4-FFF2-40B4-BE49-F238E27FC236}">
-                <a16:creationId xmlns:a16="http://schemas.microsoft.com/office/drawing/2014/main" id="{BA4791C6-7396-478A-930E-779685A6B062}"/>
+                <a16:creationId xmlns:a16="http://schemas.microsoft.com/office/drawing/2014/main" id="{CA7666D1-8789-43C7-93FF-B2BBED97F47B}"/>
               </a:ext>
             </a:extLst>
           </p:cNvPr>
@@ -4769,7 +5176,7 @@
           <p:cNvPr id="7" name="Rectangle 6">
             <a:extLst>
               <a:ext uri="{FF2B5EF4-FFF2-40B4-BE49-F238E27FC236}">
-                <a16:creationId xmlns:a16="http://schemas.microsoft.com/office/drawing/2014/main" id="{CFFA21CB-02B3-4634-BDE9-FC96A4E6D880}"/>
+                <a16:creationId xmlns:a16="http://schemas.microsoft.com/office/drawing/2014/main" id="{80616338-DD43-41A1-BBC8-C9CE80C0099C}"/>
               </a:ext>
             </a:extLst>
           </p:cNvPr>
@@ -4835,7 +5242,7 @@
           <p:cNvPr id="8" name="Rectangle 7">
             <a:extLst>
               <a:ext uri="{FF2B5EF4-FFF2-40B4-BE49-F238E27FC236}">
-                <a16:creationId xmlns:a16="http://schemas.microsoft.com/office/drawing/2014/main" id="{36BE9103-E3DA-4A9E-8FDC-79E1C7A445C4}"/>
+                <a16:creationId xmlns:a16="http://schemas.microsoft.com/office/drawing/2014/main" id="{E5BAB45C-9B87-4517-B208-73313566EF72}"/>
               </a:ext>
             </a:extLst>
           </p:cNvPr>
@@ -4901,7 +5308,7 @@
           <p:cNvPr id="9" name="Rectangle 8">
             <a:extLst>
               <a:ext uri="{FF2B5EF4-FFF2-40B4-BE49-F238E27FC236}">
-                <a16:creationId xmlns:a16="http://schemas.microsoft.com/office/drawing/2014/main" id="{D59B0E5D-6438-473D-BD62-9E097DFB2B4B}"/>
+                <a16:creationId xmlns:a16="http://schemas.microsoft.com/office/drawing/2014/main" id="{67E177F1-E099-4A54-BF39-4416AC4C6ADC}"/>
               </a:ext>
             </a:extLst>
           </p:cNvPr>
@@ -4967,7 +5374,7 @@
           <p:cNvPr id="10" name="Rectangle 9">
             <a:extLst>
               <a:ext uri="{FF2B5EF4-FFF2-40B4-BE49-F238E27FC236}">
-                <a16:creationId xmlns:a16="http://schemas.microsoft.com/office/drawing/2014/main" id="{2106CE00-72DF-4BCA-82A6-3376590610C3}"/>
+                <a16:creationId xmlns:a16="http://schemas.microsoft.com/office/drawing/2014/main" id="{87B92248-5378-44A0-8A62-5D4E094F831D}"/>
               </a:ext>
             </a:extLst>
           </p:cNvPr>
@@ -5033,7 +5440,7 @@
           <p:cNvPr id="11" name="Rectangle 10">
             <a:extLst>
               <a:ext uri="{FF2B5EF4-FFF2-40B4-BE49-F238E27FC236}">
-                <a16:creationId xmlns:a16="http://schemas.microsoft.com/office/drawing/2014/main" id="{5D8F8F84-4504-4D20-9F1B-732E36AA3229}"/>
+                <a16:creationId xmlns:a16="http://schemas.microsoft.com/office/drawing/2014/main" id="{034F020E-4A69-4606-BC5B-502BF90B70EF}"/>
               </a:ext>
             </a:extLst>
           </p:cNvPr>
@@ -5099,7 +5506,7 @@
           <p:cNvPr id="12" name="Rectangle 11">
             <a:extLst>
               <a:ext uri="{FF2B5EF4-FFF2-40B4-BE49-F238E27FC236}">
-                <a16:creationId xmlns:a16="http://schemas.microsoft.com/office/drawing/2014/main" id="{3728B635-2223-45F3-965B-AC85E887446F}"/>
+                <a16:creationId xmlns:a16="http://schemas.microsoft.com/office/drawing/2014/main" id="{356B99EE-990A-45FC-A7D5-6B61C9F2E3B9}"/>
               </a:ext>
             </a:extLst>
           </p:cNvPr>
@@ -5165,7 +5572,7 @@
           <p:cNvPr id="13" name="Rectangle 12">
             <a:extLst>
               <a:ext uri="{FF2B5EF4-FFF2-40B4-BE49-F238E27FC236}">
-                <a16:creationId xmlns:a16="http://schemas.microsoft.com/office/drawing/2014/main" id="{C34934BE-B334-4DF6-8B28-85D64BFDF8AC}"/>
+                <a16:creationId xmlns:a16="http://schemas.microsoft.com/office/drawing/2014/main" id="{450A3E45-03D8-430F-841A-FA4B43426569}"/>
               </a:ext>
             </a:extLst>
           </p:cNvPr>
@@ -5231,7 +5638,7 @@
           <p:cNvPr id="14" name="Rectangle 13">
             <a:extLst>
               <a:ext uri="{FF2B5EF4-FFF2-40B4-BE49-F238E27FC236}">
-                <a16:creationId xmlns:a16="http://schemas.microsoft.com/office/drawing/2014/main" id="{95EE93E2-2FB1-4EDD-986E-1989ADC4593A}"/>
+                <a16:creationId xmlns:a16="http://schemas.microsoft.com/office/drawing/2014/main" id="{F9990930-7622-4FBC-8A51-A185596D886A}"/>
               </a:ext>
             </a:extLst>
           </p:cNvPr>
@@ -5320,7 +5727,7 @@
           <p:cNvPr id="15" name="Rectangle 14">
             <a:extLst>
               <a:ext uri="{FF2B5EF4-FFF2-40B4-BE49-F238E27FC236}">
-                <a16:creationId xmlns:a16="http://schemas.microsoft.com/office/drawing/2014/main" id="{C9DC0D99-CCE7-448F-97E7-1EE7D7D3F713}"/>
+                <a16:creationId xmlns:a16="http://schemas.microsoft.com/office/drawing/2014/main" id="{FF1FA3DA-FD23-4212-8799-8A42F66B9B64}"/>
               </a:ext>
             </a:extLst>
           </p:cNvPr>
@@ -5386,7 +5793,7 @@
           <p:cNvPr id="16" name="Table 15">
             <a:extLst>
               <a:ext uri="{FF2B5EF4-FFF2-40B4-BE49-F238E27FC236}">
-                <a16:creationId xmlns:a16="http://schemas.microsoft.com/office/drawing/2014/main" id="{1E7AEADC-B7A6-43BC-A89D-5955CEC26359}"/>
+                <a16:creationId xmlns:a16="http://schemas.microsoft.com/office/drawing/2014/main" id="{1EF27B8C-5A9C-45B6-9CDB-F8F6F83CB53B}"/>
               </a:ext>
             </a:extLst>
           </p:cNvPr>
@@ -5739,7 +6146,7 @@
           <p:cNvPr id="17" name="Rectangle 16">
             <a:extLst>
               <a:ext uri="{FF2B5EF4-FFF2-40B4-BE49-F238E27FC236}">
-                <a16:creationId xmlns:a16="http://schemas.microsoft.com/office/drawing/2014/main" id="{875E25C3-8657-4142-B464-0F503EE99F8F}"/>
+                <a16:creationId xmlns:a16="http://schemas.microsoft.com/office/drawing/2014/main" id="{E6288486-A71E-45DE-8970-8E5D0443D86C}"/>
               </a:ext>
             </a:extLst>
           </p:cNvPr>
@@ -5826,7 +6233,7 @@
     </p:spTree>
     <p:extLst>
       <p:ext uri="{BB962C8B-B14F-4D97-AF65-F5344CB8AC3E}">
-        <p14:creationId xmlns:p14="http://schemas.microsoft.com/office/powerpoint/2010/main" val="1006084862"/>
+        <p14:creationId xmlns:p14="http://schemas.microsoft.com/office/powerpoint/2010/main" val="1933420522"/>
       </p:ext>
     </p:extLst>
   </p:cSld>
@@ -5866,7 +6273,7 @@
           <p:cNvPr id="16" name="Rectangle 15">
             <a:extLst>
               <a:ext uri="{FF2B5EF4-FFF2-40B4-BE49-F238E27FC236}">
-                <a16:creationId xmlns:a16="http://schemas.microsoft.com/office/drawing/2014/main" id="{09B9482A-ABEC-40CD-8B0E-BD2487AFEB54}"/>
+                <a16:creationId xmlns:a16="http://schemas.microsoft.com/office/drawing/2014/main" id="{F6F7248F-019D-485D-B66F-68DCF930FC40}"/>
               </a:ext>
             </a:extLst>
           </p:cNvPr>
@@ -5932,7 +6339,7 @@
           <p:cNvPr id="2" name="Rectangle 1">
             <a:extLst>
               <a:ext uri="{FF2B5EF4-FFF2-40B4-BE49-F238E27FC236}">
-                <a16:creationId xmlns:a16="http://schemas.microsoft.com/office/drawing/2014/main" id="{DBFAEBF9-E1FE-423B-8A31-D1C024AD6563}"/>
+                <a16:creationId xmlns:a16="http://schemas.microsoft.com/office/drawing/2014/main" id="{B310CBCD-3B20-4C2F-BDB3-9D2722D96E5E}"/>
               </a:ext>
             </a:extLst>
           </p:cNvPr>
@@ -5998,7 +6405,7 @@
           <p:cNvPr id="3" name="Rectangle 2">
             <a:extLst>
               <a:ext uri="{FF2B5EF4-FFF2-40B4-BE49-F238E27FC236}">
-                <a16:creationId xmlns:a16="http://schemas.microsoft.com/office/drawing/2014/main" id="{89923AA0-FEB5-444B-AC63-65843DBF9AB2}"/>
+                <a16:creationId xmlns:a16="http://schemas.microsoft.com/office/drawing/2014/main" id="{81731255-3F40-48E3-A37A-F0135A5CCE31}"/>
               </a:ext>
             </a:extLst>
           </p:cNvPr>
@@ -6064,7 +6471,7 @@
           <p:cNvPr id="4" name="Rectangle 3">
             <a:extLst>
               <a:ext uri="{FF2B5EF4-FFF2-40B4-BE49-F238E27FC236}">
-                <a16:creationId xmlns:a16="http://schemas.microsoft.com/office/drawing/2014/main" id="{DD2FF9F5-97DF-43AA-BB5C-954BFE413A77}"/>
+                <a16:creationId xmlns:a16="http://schemas.microsoft.com/office/drawing/2014/main" id="{E49FCF65-E60E-4CD4-BC5A-0B7A99714778}"/>
               </a:ext>
             </a:extLst>
           </p:cNvPr>
@@ -6130,7 +6537,7 @@
           <p:cNvPr id="5" name="Rectangle 4">
             <a:extLst>
               <a:ext uri="{FF2B5EF4-FFF2-40B4-BE49-F238E27FC236}">
-                <a16:creationId xmlns:a16="http://schemas.microsoft.com/office/drawing/2014/main" id="{77680277-A0A2-4D6E-AF42-9FECE4656B19}"/>
+                <a16:creationId xmlns:a16="http://schemas.microsoft.com/office/drawing/2014/main" id="{F2AD4EDC-1A73-4337-B954-0ED342CFD402}"/>
               </a:ext>
             </a:extLst>
           </p:cNvPr>
@@ -6196,7 +6603,7 @@
           <p:cNvPr id="6" name="Rectangle 5">
             <a:extLst>
               <a:ext uri="{FF2B5EF4-FFF2-40B4-BE49-F238E27FC236}">
-                <a16:creationId xmlns:a16="http://schemas.microsoft.com/office/drawing/2014/main" id="{10DF7FE0-31AF-4D26-AD43-AD75BFAB9909}"/>
+                <a16:creationId xmlns:a16="http://schemas.microsoft.com/office/drawing/2014/main" id="{30B7D8A8-1533-4E72-9B98-0257BBF6713F}"/>
               </a:ext>
             </a:extLst>
           </p:cNvPr>
@@ -6262,7 +6669,7 @@
           <p:cNvPr id="7" name="Rectangle 6">
             <a:extLst>
               <a:ext uri="{FF2B5EF4-FFF2-40B4-BE49-F238E27FC236}">
-                <a16:creationId xmlns:a16="http://schemas.microsoft.com/office/drawing/2014/main" id="{308C7E66-1C40-4515-A048-BDB29FAF249B}"/>
+                <a16:creationId xmlns:a16="http://schemas.microsoft.com/office/drawing/2014/main" id="{E2BDB2CF-50F8-4A4E-80A4-D036A92F151C}"/>
               </a:ext>
             </a:extLst>
           </p:cNvPr>
@@ -6328,7 +6735,7 @@
           <p:cNvPr id="8" name="Rectangle 7">
             <a:extLst>
               <a:ext uri="{FF2B5EF4-FFF2-40B4-BE49-F238E27FC236}">
-                <a16:creationId xmlns:a16="http://schemas.microsoft.com/office/drawing/2014/main" id="{632EDA3F-F278-4A08-9A85-BE0D90B1BE26}"/>
+                <a16:creationId xmlns:a16="http://schemas.microsoft.com/office/drawing/2014/main" id="{1D128EE6-716E-4BC2-89CF-8E77B34301E2}"/>
               </a:ext>
             </a:extLst>
           </p:cNvPr>
@@ -6394,7 +6801,7 @@
           <p:cNvPr id="9" name="Rectangle 8">
             <a:extLst>
               <a:ext uri="{FF2B5EF4-FFF2-40B4-BE49-F238E27FC236}">
-                <a16:creationId xmlns:a16="http://schemas.microsoft.com/office/drawing/2014/main" id="{9E6C60B0-FE10-4CC5-B2B1-0740ABE43EBF}"/>
+                <a16:creationId xmlns:a16="http://schemas.microsoft.com/office/drawing/2014/main" id="{183DF161-B823-4283-B201-64B104DF2C3F}"/>
               </a:ext>
             </a:extLst>
           </p:cNvPr>
@@ -6460,7 +6867,7 @@
           <p:cNvPr id="10" name="Rectangle 9">
             <a:extLst>
               <a:ext uri="{FF2B5EF4-FFF2-40B4-BE49-F238E27FC236}">
-                <a16:creationId xmlns:a16="http://schemas.microsoft.com/office/drawing/2014/main" id="{61311EE0-8602-4EDF-BCDC-7F46E755DD33}"/>
+                <a16:creationId xmlns:a16="http://schemas.microsoft.com/office/drawing/2014/main" id="{8361B1D2-1620-42C3-8D69-3A4C417DFEB2}"/>
               </a:ext>
             </a:extLst>
           </p:cNvPr>
@@ -6526,7 +6933,7 @@
           <p:cNvPr id="11" name="Rectangle 10">
             <a:extLst>
               <a:ext uri="{FF2B5EF4-FFF2-40B4-BE49-F238E27FC236}">
-                <a16:creationId xmlns:a16="http://schemas.microsoft.com/office/drawing/2014/main" id="{38877E40-F6D8-4034-90EE-CFFF0C97C9DD}"/>
+                <a16:creationId xmlns:a16="http://schemas.microsoft.com/office/drawing/2014/main" id="{140E2A48-9FD5-4359-B2B0-BFE350E60ED3}"/>
               </a:ext>
             </a:extLst>
           </p:cNvPr>
@@ -6592,7 +6999,7 @@
           <p:cNvPr id="12" name="Rectangle 11">
             <a:extLst>
               <a:ext uri="{FF2B5EF4-FFF2-40B4-BE49-F238E27FC236}">
-                <a16:creationId xmlns:a16="http://schemas.microsoft.com/office/drawing/2014/main" id="{1E2CA329-5806-4763-8089-1BAED5335201}"/>
+                <a16:creationId xmlns:a16="http://schemas.microsoft.com/office/drawing/2014/main" id="{8CC38B9C-FE55-4AF7-A1F8-509FE56B595E}"/>
               </a:ext>
             </a:extLst>
           </p:cNvPr>
@@ -6704,7 +7111,7 @@
           <p:cNvPr id="13" name="Rectangle 12">
             <a:extLst>
               <a:ext uri="{FF2B5EF4-FFF2-40B4-BE49-F238E27FC236}">
-                <a16:creationId xmlns:a16="http://schemas.microsoft.com/office/drawing/2014/main" id="{9580453F-1B10-42E3-9BFC-6CF0ABBE642B}"/>
+                <a16:creationId xmlns:a16="http://schemas.microsoft.com/office/drawing/2014/main" id="{5F29FFD2-77CB-4EC7-B839-89AFEEEE06A2}"/>
               </a:ext>
             </a:extLst>
           </p:cNvPr>
@@ -6770,7 +7177,7 @@
           <p:cNvPr id="14" name="Rectangle 13">
             <a:extLst>
               <a:ext uri="{FF2B5EF4-FFF2-40B4-BE49-F238E27FC236}">
-                <a16:creationId xmlns:a16="http://schemas.microsoft.com/office/drawing/2014/main" id="{FBB45FF0-C40B-4450-8F53-FA809D7AC7D8}"/>
+                <a16:creationId xmlns:a16="http://schemas.microsoft.com/office/drawing/2014/main" id="{86476A61-A471-4BEF-9733-CE253AB802B2}"/>
               </a:ext>
             </a:extLst>
           </p:cNvPr>
@@ -6882,7 +7289,7 @@
           <p:cNvPr id="15" name="Rectangle 14">
             <a:extLst>
               <a:ext uri="{FF2B5EF4-FFF2-40B4-BE49-F238E27FC236}">
-                <a16:creationId xmlns:a16="http://schemas.microsoft.com/office/drawing/2014/main" id="{F40CA269-39D5-4068-A89C-18F9B56AC90C}"/>
+                <a16:creationId xmlns:a16="http://schemas.microsoft.com/office/drawing/2014/main" id="{388A86FB-EF4F-4F5B-BB8E-004AA9767FF8}"/>
               </a:ext>
             </a:extLst>
           </p:cNvPr>
@@ -6946,7 +7353,7 @@
     </p:spTree>
     <p:extLst>
       <p:ext uri="{BB962C8B-B14F-4D97-AF65-F5344CB8AC3E}">
-        <p14:creationId xmlns:p14="http://schemas.microsoft.com/office/powerpoint/2010/main" val="251656051"/>
+        <p14:creationId xmlns:p14="http://schemas.microsoft.com/office/powerpoint/2010/main" val="208566896"/>
       </p:ext>
     </p:extLst>
   </p:cSld>

</xml_diff>